<commit_message>
Expand English narration to eight minutes with slide-by-slide scripts
</commit_message>
<xml_diff>
--- a/downloads/REPLAY_LAB_Presentation.pptx
+++ b/downloads/REPLAY_LAB_Presentation.pptx
@@ -519,7 +519,7 @@
           <a:lstStyle/>
           <a:p>
             <a:r>
-              <a:t>0:00–0:10 | Spot the change</a:t>
+              <a:t>0:00–0:20 | Spot the change</a:t>
             </a:r>
           </a:p>
           <a:p/>
@@ -530,7 +530,7 @@
           </a:p>
           <a:p>
             <a:r>
-              <a:t>A toy can carry a memory. REPLAY LAB explores how working adults might turn childhood wishes into personal squishies and slime.</a:t>
+              <a:t>Hello everyone. Think about a toy you wanted as a child but never bought. What would it mean to buy it today, with your own money? That question is the starting point for REPLAY LAB: a proposed business connecting childhood memories with personalised squishies and slime.</a:t>
             </a:r>
           </a:p>
           <a:p/>
@@ -611,7 +611,7 @@
           <a:lstStyle/>
           <a:p>
             <a:r>
-              <a:t>2:20–2:35 | Find the opportunity</a:t>
+              <a:t>3:50–4:15 | Find the opportunity</a:t>
             </a:r>
           </a:p>
           <a:p/>
@@ -622,7 +622,7 @@
           </a:p>
           <a:p>
             <a:r>
-              <a:t>The studio has four steps: shape, colour, feel and story. Customers choose available options and add a name. Quiet and unscented settings suit a possible desk-use preference, subject to physical testing.</a:t>
+              <a:t>The website turns that idea into four design steps: shape, colour, feel and story. A customer chooses the product, changes its appearance, selects sensory preferences and adds a name or memory. For a desk, they might prefer quiet and unscented options. The screen demonstrates those choices, but it cannot prove the real texture or smell. Physical samples would still be essential.</a:t>
             </a:r>
           </a:p>
           <a:p/>
@@ -703,7 +703,7 @@
           <a:lstStyle/>
           <a:p>
             <a:r>
-              <a:t>2:35–3:00 | Find the opportunity</a:t>
+              <a:t>4:15–4:55 | Find the opportunity</a:t>
             </a:r>
           </a:p>
           <a:p/>
@@ -714,18 +714,30 @@
           </a:p>
           <a:p>
             <a:r>
-              <a:t>Watch the ordering demo. Choose a shape, change its colour, name the design and save it. Add it to the bag, review the illustrative price, then confirm a simulated reservation. The notebook keeps the result. This is a prototype: no payment is taken and no product is ordered.</a:t>
+              <a:t>Let me show how the prototype works, from design to a saved reservation.</a:t>
             </a:r>
           </a:p>
           <a:p/>
           <a:p>
             <a:r>
+              <a:t>First, choose a gamepad shape. Change its colour, then name it Saturday Save Point. Save the design and add it to the demo bag. Review the illustrative price and confirm that this is a simulation. After confirming, the reservation appears in the notebook. No payment is taken and no product is ordered.</a:t>
+            </a:r>
+          </a:p>
+          <a:p/>
+          <a:p>
+            <a:r>
+              <a:t>A real launch would also need supplier checks and clear production or refund terms.</a:t>
+            </a:r>
+          </a:p>
+          <a:p/>
+          <a:p>
+            <a:r>
               <a:t>VISUAL CUE</a:t>
             </a:r>
           </a:p>
           <a:p>
             <a:r>
-              <a:t>Click the embedded MP4 in slideshow mode and narrate over its 25 seconds. This clip is already included in the timeline. If playback is unavailable, open the downloadable MP4 before recording. Do not add a second demo interval.</a:t>
+              <a:t>0–7 seconds: read the introduction with the poster visible. At 7 seconds, click the embedded 25-second MP4 and read the middle paragraph over it. Use the final 8 seconds for the closing paragraph. The full 40-second slide slot already includes the demo; do not add another 25 seconds. Use the standalone MP4 if your presentation application cannot play the embedded clip.</a:t>
             </a:r>
           </a:p>
         </p:txBody>
@@ -795,7 +807,7 @@
           <a:lstStyle/>
           <a:p>
             <a:r>
-              <a:t>3:00–3:15 | Find the opportunity</a:t>
+              <a:t>4:55–5:20 | Find the opportunity</a:t>
             </a:r>
           </a:p>
           <a:p/>
@@ -806,7 +818,7 @@
           </a:p>
           <a:p>
             <a:r>
-              <a:t>Custom squishies already exist. Our proposed difference combines Thai childhood memories, adult use and customer-chosen collections. Shared shapes and supplier processes control complexity; colours, names and memory cards add personal meaning.</a:t>
+              <a:t>This raises an important business question: how can we offer personal meaning without making every item completely from scratch? My proposal uses shared shapes within a collection, while customers choose selected details and memory cards. Custom squishies already exist, so I am not claiming global originality. The proposed difference is the combination of Thai childhood memories, adult use and customer participation.</a:t>
             </a:r>
           </a:p>
           <a:p/>
@@ -887,7 +899,7 @@
           <a:lstStyle/>
           <a:p>
             <a:r>
-              <a:t>3:15–3:30 | Find the opportunity</a:t>
+              <a:t>5:20–5:45 | Find the opportunity</a:t>
             </a:r>
           </a:p>
           <a:p/>
@@ -898,7 +910,7 @@
           </a:p>
           <a:p>
             <a:r>
-              <a:t>Revenue would come from product sales and selected upgrades. The demo starts squishies at three hundred forty-nine baht and slime at two hundred ninety-nine. These are illustrative prices, not validated offers.</a:t>
+              <a:t>Revenue would come from selling the products and a limited range of upgrades. In the demo, squishies start at three hundred forty-nine baht and slime at two hundred ninety-nine baht. Larger sizes, finishing details or gift sleeves add to the price. These are illustrative amounts. We still need supplier quotes and customer testing to find a price that works for both sides.</a:t>
             </a:r>
           </a:p>
           <a:p/>
@@ -979,7 +991,7 @@
           <a:lstStyle/>
           <a:p>
             <a:r>
-              <a:t>3:30–3:50 | Evaluate the opportunity</a:t>
+              <a:t>5:45–6:20 | Evaluate the opportunity</a:t>
             </a:r>
           </a:p>
           <a:p/>
@@ -990,7 +1002,7 @@
           </a:p>
           <a:p>
             <a:r>
-              <a:t>Three risks need tests: customers may prefer a cheaper toy, custom options can complicate production, and nostalgia may drive only one purchase. Compare prototype preferences, check supplier samples and explore repeat-use reasons. Product information also needs checking, as the OCPB report illustrates.</a:t>
+              <a:t>There are three main risks. First, customers may like the idea but choose a cheaper toy. We should compare prototypes at realistic prices. Second, too many options could create production problems, so we should limit the range and check samples. Third, nostalgia may lead to only one purchase. We need to understand repeat-use or gifting reasons. The OCPB report also highlights product-information concerns at some sellers, making supplier and label checks part of the proposed launch process.</a:t>
             </a:r>
           </a:p>
           <a:p/>
@@ -1071,7 +1083,7 @@
           <a:lstStyle/>
           <a:p>
             <a:r>
-              <a:t>3:50–4:15 | Evaluate the opportunity</a:t>
+              <a:t>6:20–7:00 | Evaluate the opportunity</a:t>
             </a:r>
           </a:p>
           <a:p/>
@@ -1082,7 +1094,7 @@
           </a:p>
           <a:p>
             <a:r>
-              <a:t>The economics are assumptions. Three hundred forty-nine baht minus one hundred ninety-nine leaves one hundred fifty per unit. Four thousand five hundred in setup costs therefore requires thirty units. The actual threshold must also meet supplier minimums and include every relevant cost.</a:t>
+              <a:t>Now let us look at the illustrative economics. If a squishy sells for three hundred forty-nine baht and its variable cost is one hundred ninety-nine, the contribution is one hundred fifty baht per unit. This is the amount available to cover fixed costs, not final profit. With four thousand five hundred baht in setup costs, thirty units would cover that setup amount. The actual threshold must also meet the supplier’s minimum and account for all relevant costs, including fees, defects and delivery.</a:t>
             </a:r>
           </a:p>
           <a:p/>
@@ -1163,7 +1175,7 @@
           <a:lstStyle/>
           <a:p>
             <a:r>
-              <a:t>4:15–4:30 | Evaluate the opportunity</a:t>
+              <a:t>7:00–7:25 | Evaluate the opportunity</a:t>
             </a:r>
           </a:p>
           <a:p/>
@@ -1174,7 +1186,7 @@
           </a:p>
           <a:p>
             <a:r>
-              <a:t>First, interview actual buyers. Then show the concept and prototype at a viable price. Finally, confirm supplier quality, costs and terms before a real purchase test. Survey interest alone is insufficient.</a:t>
+              <a:t>To test the idea, I would follow three stages. First, ask actual buyers about their recent purchases. Second, introduce the concept and compare reactions to a prototype at a viable price. Third, confirm supplier samples, costs and terms before testing real orders. The questionnaire supports this process, but positive answers alone do not prove demand. Website demo reservations are also not real sales.</a:t>
             </a:r>
           </a:p>
           <a:p/>
@@ -1255,7 +1267,7 @@
           <a:lstStyle/>
           <a:p>
             <a:r>
-              <a:t>4:30–4:45 | Evaluate the opportunity</a:t>
+              <a:t>7:25–7:50 | Evaluate the opportunity</a:t>
             </a:r>
           </a:p>
           <a:p/>
@@ -1266,7 +1278,7 @@
           </a:p>
           <a:p>
             <a:r>
-              <a:t>Start with one collection. Continue only when people prefer it at a viable price, quality is consistent, and orders cover the batch. Let weak results change the idea.</a:t>
+              <a:t>My recommendation is to begin with one collection and three decision rules. Customers must choose it at a viable price, product quality must be consistent, and confirmed orders must cover the batch. If those conditions fail, we should change the idea before expanding. REPLAY LAB offers a way to explore a childhood memory as a product, with evidence guiding what happens next.</a:t>
             </a:r>
           </a:p>
           <a:p/>
@@ -1347,7 +1359,7 @@
           <a:lstStyle/>
           <a:p>
             <a:r>
-              <a:t>4:45–4:50 | Credits</a:t>
+              <a:t>7:50–8:00 | Credits</a:t>
             </a:r>
           </a:p>
           <a:p/>
@@ -1356,8 +1368,12 @@
               <a:t>NARRATION</a:t>
             </a:r>
           </a:p>
+          <a:p>
+            <a:r>
+              <a:t>These are the sources and prototype behind the proposal. The supporting files include the questionnaire and assumptions. Thank you for listening.</a:t>
+            </a:r>
+          </a:p>
           <a:p/>
-          <a:p/>
           <a:p>
             <a:r>
               <a:t>VISUAL CUE</a:t>
@@ -1365,7 +1381,7 @@
           </a:p>
           <a:p>
             <a:r>
-              <a:t>Silent five-second source card. All eighteen slides are part of the presentation; full source notes accompany the files.</a:t>
+              <a:t>Keep the source card visible while saying the closing lines. No extra silent credit interval is needed; this ten-second slide is included in the eight minutes.</a:t>
             </a:r>
           </a:p>
         </p:txBody>
@@ -1435,7 +1451,7 @@
           <a:lstStyle/>
           <a:p>
             <a:r>
-              <a:t>0:10–0:25 | Spot the change</a:t>
+              <a:t>0:20–0:45 | Spot the change</a:t>
             </a:r>
           </a:p>
           <a:p/>
@@ -1446,7 +1462,7 @@
           </a:p>
           <a:p>
             <a:r>
-              <a:t>Thai PBS World reported a toy revival at Sampheng in June twenty twenty-six. Thairath reported a broader revival at Mega Plaza. These are local signals, not a market-size estimate.</a:t>
+              <a:t>First, let us look at the signal behind this idea. Thai PBS World reported renewed interest in squishies and slime at Sampheng in June twenty twenty-six. Thairath also covered a revival at Mega Plaza. These reports give us a reason to investigate. However, they describe particular places and moments, rather than proving the size or future growth of the whole market.</a:t>
             </a:r>
           </a:p>
           <a:p/>
@@ -1527,7 +1543,7 @@
           <a:lstStyle/>
           <a:p>
             <a:r>
-              <a:t>0:25–0:40 | Spot the change</a:t>
+              <a:t>0:45–1:10 | Spot the change</a:t>
             </a:r>
           </a:p>
           <a:p/>
@@ -1538,7 +1554,7 @@
           </a:p>
           <a:p>
             <a:r>
-              <a:t>The Sampheng vendor described working adults buying toys they had wanted but could not afford as children. The product is familiar; adult income changes the buyer’s freedom to choose.</a:t>
+              <a:t>The interesting change is not simply that toys are popular again. It is that some buyers now have a different relationship with them. The Sampheng report includes a vendor’s account of working adults buying toys they wanted when they were younger. A childhood wish that once depended on their parents can now become a purchase they choose for themselves.</a:t>
             </a:r>
           </a:p>
           <a:p/>
@@ -1619,7 +1635,7 @@
           <a:lstStyle/>
           <a:p>
             <a:r>
-              <a:t>0:40–0:55 | Spot the change</a:t>
+              <a:t>1:10–1:35 | Spot the change</a:t>
             </a:r>
           </a:p>
           <a:p/>
@@ -1630,7 +1646,7 @@
           </a:p>
           <a:p>
             <a:r>
-              <a:t>Original fieldwork is still pending. Mega Plaza’s observed buyers were mainly children and teenagers. I need direct evidence from working adults, asking about actual purchases before showing the business idea.</a:t>
+              <a:t>Before explaining the business, I want to separate published evidence from my own research. Original fieldwork is still pending, and the Mega Plaza report mainly observed children and teenagers. It does not independently confirm adult demand. My next step is to interview working adults about their actual purchases, before showing them REPLAY LAB, so the concept does not shape their initial answers.</a:t>
             </a:r>
           </a:p>
           <a:p/>
@@ -1722,7 +1738,7 @@
           <a:lstStyle/>
           <a:p>
             <a:r>
-              <a:t>0:55–1:10 | Explain the consumer</a:t>
+              <a:t>1:35–2:00 | Explain the consumer</a:t>
             </a:r>
           </a:p>
           <a:p/>
@@ -1733,7 +1749,7 @@
           </a:p>
           <a:p>
             <a:r>
-              <a:t>The proposed target is early-career Thai adults buying for their own enjoyment or collection. A desk, display or everyday break provides a possible use context. These preferences still need testing.</a:t>
+              <a:t>Based on that signal, my proposed target is early-career Thai adults who buy toys for themselves, rather than for children. They might keep a small object on a desk, display it at home, or enjoy using it during a break. These are possible use situations to test. The key question is which memories and product features matter to this specific group.</a:t>
             </a:r>
           </a:p>
           <a:p/>
@@ -1814,7 +1830,7 @@
           <a:lstStyle/>
           <a:p>
             <a:r>
-              <a:t>1:10–1:30 | Explain the consumer</a:t>
+              <a:t>2:00–2:30 | Explain the consumer</a:t>
             </a:r>
           </a:p>
           <a:p/>
@@ -1825,7 +1841,7 @@
           </a:p>
           <a:p>
             <a:r>
-              <a:t>Emotional motivation explains why a familiar object may matter. Memory adds personal meaning, texture offers enjoyment, and adult income enables choice. My interpretation is that these benefits can combine. Whether buyers would pay more remains an open question.</a:t>
+              <a:t>The first consumer behaviour concept is emotional motivation. A familiar shape may remind someone of an after-school routine or a game they enjoyed. The texture may also be enjoyable on its own. Adult income then gives that person more freedom to choose. My interpretation is that memory, enjoyment and choice could work together. However, emotional meaning does not automatically mean customers will pay a higher price.</a:t>
             </a:r>
           </a:p>
           <a:p/>
@@ -1906,7 +1922,7 @@
           <a:lstStyle/>
           <a:p>
             <a:r>
-              <a:t>1:30–1:50 | Explain the consumer</a:t>
+              <a:t>2:30–3:00 | Explain the consumer</a:t>
             </a:r>
           </a:p>
           <a:p/>
@@ -1917,7 +1933,7 @@
           </a:p>
           <a:p>
             <a:r>
-              <a:t>Social influence helps explain rediscovery. Reviews bring toys back into view, and seeing other adults play may make buying feel acceptable. Discovery and motivation differ: a review may attract attention while memory explains the choice. Paid demand still needs testing.</a:t>
+              <a:t>The second concept is social influence. Online reviews can bring an old toy back into someone’s attention. Seeing other adults enjoy it may also make the purchase feel more acceptable. But discovery and motivation are different. A review could make someone notice a squishy, while a personal memory gives them a reason to choose it. We therefore need to ask both how they discovered the toy and why they actually bought it.</a:t>
             </a:r>
           </a:p>
           <a:p/>
@@ -1998,7 +2014,7 @@
           <a:lstStyle/>
           <a:p>
             <a:r>
-              <a:t>1:50–2:05 | Find the opportunity</a:t>
+              <a:t>3:00–3:25 | Find the opportunity</a:t>
             </a:r>
           </a:p>
           <a:p/>
@@ -2009,7 +2025,7 @@
           </a:p>
           <a:p>
             <a:r>
-              <a:t>Our proposed value is simple: bring a familiar memory into everyday life. Customers get a recognisable theme, personal design choices and clear product information. This is a hypothesis to test.</a:t>
+              <a:t>These ideas lead to the proposed value: bring a familiar memory into everyday life. REPLAY LAB combines three benefits. Meaning comes from a childhood reference. Choice comes from personal details. Confidence would come from clear samples, prices and order terms. The business needs to test whether customers value this combination enough to choose it over an ordinary toy.</a:t>
             </a:r>
           </a:p>
           <a:p/>
@@ -2090,7 +2106,7 @@
           <a:lstStyle/>
           <a:p>
             <a:r>
-              <a:t>2:05–2:20 | Find the opportunity</a:t>
+              <a:t>3:25–3:50 | Find the opportunity</a:t>
             </a:r>
           </a:p>
           <a:p/>
@@ -2101,7 +2117,7 @@
           </a:p>
           <a:p>
             <a:r>
-              <a:t>The starting collection includes a pencil-case squishy, a gamepad squishy and cloud slime. Shared childhood themes connect the objects, while a small range of shapes keeps the proposed production manageable.</a:t>
+              <a:t>Here are three starting concepts: a pencil-case squishy, a gamepad squishy and cloud slime. Each suggests a different childhood moment, such as school supplies, weekend games or a treat after school. These are proposed themes, not proven customer preferences. Starting with a small selection would let us test which theme connects with buyers before spending money on more designs.</a:t>
             </a:r>
           </a:p>
           <a:p/>
@@ -14536,7 +14552,7 @@
                 </a:solidFill>
                 <a:latin typeface="Arial"/>
               </a:rPr>
-              <a:t>CREDITS / 4:45–4:50</a:t>
+              <a:t>SOURCES / 7:50–8:00</a:t>
             </a:r>
           </a:p>
         </p:txBody>

</xml_diff>

<commit_message>
Include presenter market interview as qualitative field evidence
</commit_message>
<xml_diff>
--- a/downloads/REPLAY_LAB_Presentation.pptx
+++ b/downloads/REPLAY_LAB_Presentation.pptx
@@ -1186,7 +1186,7 @@
           </a:p>
           <a:p>
             <a:r>
-              <a:t>To test the idea, I would follow three stages. First, ask actual buyers about their recent purchases. Second, introduce the concept and compare reactions to a prototype at a viable price. Third, confirm supplier samples, costs and terms before testing real orders. The questionnaire supports this process, but positive answers alone do not prove demand. Website demo reservations are also not real sales.</a:t>
+              <a:t>To develop this initial interview, I would follow three stages. First, ask adult buyers about their recent purchases and reasons for trying the toys. Second, compare reactions to the concept at a viable price. Third, confirm supplier samples, costs and terms before testing real orders. The questionnaire supports this process, but positive answers and website demo reservations do not prove real demand.</a:t>
             </a:r>
           </a:p>
           <a:p/>
@@ -1646,7 +1646,7 @@
           </a:p>
           <a:p>
             <a:r>
-              <a:t>Before explaining the business, I want to separate published evidence from my own research. Original fieldwork is still pending, and the Mega Plaza report mainly observed children and teenagers. It does not independently confirm adult demand. My next step is to interview working adults about their actual purchases, before showing them REPLAY LAB, so the concept does not shape their initial answers.</a:t>
+              <a:t>For my own evidence, I interviewed someone at a market near my internship. They told me that working adults also often come to squeeze and play with these toys. This suggests interest in the hands-on experience. However, it is an interview account, not a count of customers. It does not establish purchases, childhood nostalgia or growth over time.</a:t>
             </a:r>
           </a:p>
           <a:p/>
@@ -1657,18 +1657,13 @@
           </a:p>
           <a:p>
             <a:r>
-              <a:t>Replace this plan with actual dated observations, buyer counts and one consented quote before submission. Published news is not personal fieldwork.</a:t>
+              <a:t>Present S6 as an English paraphrase of the informal interview you described, not a verbatim quotation or direct observation. The market name, interview date and interviewee role have not yet been supplied. Add these only when confirmed. Do not turn the description of many adults into a numerical result.</a:t>
             </a:r>
           </a:p>
           <a:p/>
           <a:p>
             <a:r>
-              <a:t>REPLACE AFTER REAL FIELDWORK:</a:t>
-            </a:r>
-          </a:p>
-          <a:p>
-            <a:r>
-              <a:t>On [DATE], I visited [N] shops in [PLACE] and interviewed [N] working-adult buyers. [X] mentioned childhood memories; [Y] mentioned online reviews. One said, [EXACT QUOTE]. This small convenience sample [supports / complicates] the reported pattern.</a:t>
+              <a:t>SOURCE LIMIT: Interviewee role, market name and interview date are not yet supplied. Add only confirmed details. This account is not a direct quote or a measured customer count.</a:t>
             </a:r>
           </a:p>
         </p:txBody>
@@ -1841,7 +1836,7 @@
           </a:p>
           <a:p>
             <a:r>
-              <a:t>The first consumer behaviour concept is emotional motivation. A familiar shape may remind someone of an after-school routine or a game they enjoyed. The texture may also be enjoyable on its own. Adult income then gives that person more freedom to choose. My interpretation is that memory, enjoyment and choice could work together. However, emotional meaning does not automatically mean customers will pay a higher price.</a:t>
+              <a:t>The first consumer behaviour concept is emotional motivation. My interview account points to the appeal of touching and playing with the toys. The published report adds a possible link to childhood wishes. I interpret these as two possible benefits: sensory enjoyment and personal meaning. However, the interview did not establish nostalgia or willingness to pay. Those explanations still need direct questions to adult buyers.</a:t>
             </a:r>
           </a:p>
           <a:p/>
@@ -1852,7 +1847,7 @@
           </a:p>
           <a:p>
             <a:r>
-              <a:t>Explain memory, enjoyment and choice as an interpretation to test. No medical benefit or price premium is established.</a:t>
+              <a:t>Separate S6, which reports adult squeezing and playing, from S1, which supplies the childhood-wish account. Sensory enjoyment and nostalgia are interpretations, not motives confirmed by the local interview.</a:t>
             </a:r>
           </a:p>
         </p:txBody>
@@ -5816,7 +5811,7 @@
                 </a:solidFill>
                 <a:latin typeface="Arial"/>
               </a:rPr>
-              <a:t>Business proposal / Interactive prototype / Original fieldwork pending.</a:t>
+              <a:t>Business proposal / Interactive prototype / Initial informal interview included; further validation needed.</a:t>
             </a:r>
           </a:p>
         </p:txBody>
@@ -14436,7 +14431,7 @@
                 </a:solidFill>
                 <a:latin typeface="Arial"/>
               </a:rPr>
-              <a:t>Next step / Collect original buyer evidence, test the concept and confirm supplier economics.</a:t>
+              <a:t>Next step / Extend the initial interview with adult-buyer research, concept testing and supplier checks.</a:t>
             </a:r>
           </a:p>
         </p:txBody>
@@ -14816,7 +14811,7 @@
         </p:nvCxnSpPr>
         <p:spPr>
           <a:xfrm>
-            <a:off x="584200" y="2692400"/>
+            <a:off x="584200" y="2616200"/>
             <a:ext cx="6934200" cy="0"/>
           </a:xfrm>
           <a:prstGeom prst="line">
@@ -14851,7 +14846,7 @@
         </p:nvSpPr>
         <p:spPr>
           <a:xfrm>
-            <a:off x="584200" y="2895600"/>
+            <a:off x="584200" y="2819400"/>
             <a:ext cx="571500" cy="254000"/>
           </a:xfrm>
           <a:prstGeom prst="rect">
@@ -14896,7 +14891,7 @@
         </p:nvSpPr>
         <p:spPr>
           <a:xfrm>
-            <a:off x="1295400" y="2844800"/>
+            <a:off x="1295400" y="2768600"/>
             <a:ext cx="6210300" cy="364998"/>
           </a:xfrm>
           <a:prstGeom prst="rect">
@@ -14942,7 +14937,7 @@
         </p:nvCxnSpPr>
         <p:spPr>
           <a:xfrm>
-            <a:off x="584200" y="3340100"/>
+            <a:off x="584200" y="3187700"/>
             <a:ext cx="6934200" cy="0"/>
           </a:xfrm>
           <a:prstGeom prst="line">
@@ -14977,7 +14972,7 @@
         </p:nvSpPr>
         <p:spPr>
           <a:xfrm>
-            <a:off x="584200" y="3543300"/>
+            <a:off x="584200" y="3390900"/>
             <a:ext cx="571500" cy="254000"/>
           </a:xfrm>
           <a:prstGeom prst="rect">
@@ -15022,7 +15017,7 @@
         </p:nvSpPr>
         <p:spPr>
           <a:xfrm>
-            <a:off x="1295400" y="3492500"/>
+            <a:off x="1295400" y="3340100"/>
             <a:ext cx="6210300" cy="364998"/>
           </a:xfrm>
           <a:prstGeom prst="rect">
@@ -15068,7 +15063,7 @@
         </p:nvCxnSpPr>
         <p:spPr>
           <a:xfrm>
-            <a:off x="584200" y="3987800"/>
+            <a:off x="584200" y="3759200"/>
             <a:ext cx="6934200" cy="0"/>
           </a:xfrm>
           <a:prstGeom prst="line">
@@ -15103,7 +15098,7 @@
         </p:nvSpPr>
         <p:spPr>
           <a:xfrm>
-            <a:off x="584200" y="4191000"/>
+            <a:off x="584200" y="3962400"/>
             <a:ext cx="571500" cy="254000"/>
           </a:xfrm>
           <a:prstGeom prst="rect">
@@ -15148,7 +15143,7 @@
         </p:nvSpPr>
         <p:spPr>
           <a:xfrm>
-            <a:off x="1295400" y="4140200"/>
+            <a:off x="1295400" y="3911600"/>
             <a:ext cx="6210300" cy="364998"/>
           </a:xfrm>
           <a:prstGeom prst="rect">
@@ -15194,7 +15189,7 @@
         </p:nvCxnSpPr>
         <p:spPr>
           <a:xfrm>
-            <a:off x="584200" y="4635500"/>
+            <a:off x="584200" y="4330700"/>
             <a:ext cx="6934200" cy="0"/>
           </a:xfrm>
           <a:prstGeom prst="line">
@@ -15229,7 +15224,7 @@
         </p:nvSpPr>
         <p:spPr>
           <a:xfrm>
-            <a:off x="584200" y="4838700"/>
+            <a:off x="584200" y="4533900"/>
             <a:ext cx="571500" cy="254000"/>
           </a:xfrm>
           <a:prstGeom prst="rect">
@@ -15274,7 +15269,7 @@
         </p:nvSpPr>
         <p:spPr>
           <a:xfrm>
-            <a:off x="1295400" y="4787900"/>
+            <a:off x="1295400" y="4483100"/>
             <a:ext cx="6210300" cy="364998"/>
           </a:xfrm>
           <a:prstGeom prst="rect">
@@ -15312,9 +15307,134 @@
           </a:p>
         </p:txBody>
       </p:sp>
-      <p:sp>
-        <p:nvSpPr>
-          <p:cNvPr id="22" name="Rounded Rectangle 21"/>
+      <p:cxnSp>
+        <p:nvCxnSpPr>
+          <p:cNvPr id="22" name="Connector 21"/>
+          <p:cNvCxnSpPr/>
+          <p:nvPr/>
+        </p:nvCxnSpPr>
+        <p:spPr>
+          <a:xfrm>
+            <a:off x="584200" y="4902200"/>
+            <a:ext cx="6934200" cy="0"/>
+          </a:xfrm>
+          <a:prstGeom prst="line">
+            <a:avLst/>
+          </a:prstGeom>
+          <a:ln w="12700">
+            <a:solidFill>
+              <a:srgbClr val="DDD4DD"/>
+            </a:solidFill>
+          </a:ln>
+        </p:spPr>
+        <p:style>
+          <a:lnRef idx="2">
+            <a:schemeClr val="accent1"/>
+          </a:lnRef>
+          <a:fillRef idx="0">
+            <a:schemeClr val="accent1"/>
+          </a:fillRef>
+          <a:effectRef idx="1">
+            <a:schemeClr val="accent1"/>
+          </a:effectRef>
+          <a:fontRef idx="minor">
+            <a:schemeClr val="tx1"/>
+          </a:fontRef>
+        </p:style>
+      </p:cxnSp>
+      <p:sp>
+        <p:nvSpPr>
+          <p:cNvPr id="23" name="TextBox 22"/>
+          <p:cNvSpPr txBox="1"/>
+          <p:nvPr/>
+        </p:nvSpPr>
+        <p:spPr>
+          <a:xfrm>
+            <a:off x="584200" y="5105400"/>
+            <a:ext cx="571500" cy="254000"/>
+          </a:xfrm>
+          <a:prstGeom prst="rect">
+            <a:avLst/>
+          </a:prstGeom>
+          <a:noFill/>
+        </p:spPr>
+        <p:txBody>
+          <a:bodyPr wrap="none" lIns="0" rIns="0" tIns="0" bIns="0" anchor="t">
+            <a:spAutoFit/>
+          </a:bodyPr>
+          <a:lstStyle/>
+          <a:p>
+            <a:pPr>
+              <a:lnSpc>
+                <a:spcPts val="1200"/>
+              </a:lnSpc>
+              <a:spcBef>
+                <a:spcPts val="0"/>
+              </a:spcBef>
+              <a:spcAft>
+                <a:spcPts val="0"/>
+              </a:spcAft>
+            </a:pPr>
+            <a:r>
+              <a:rPr sz="800" b="0" i="0">
+                <a:solidFill>
+                  <a:srgbClr val="392C42"/>
+                </a:solidFill>
+                <a:latin typeface="Press Start 2P"/>
+              </a:rPr>
+              <a:t>S6</a:t>
+            </a:r>
+          </a:p>
+        </p:txBody>
+      </p:sp>
+      <p:sp>
+        <p:nvSpPr>
+          <p:cNvPr id="24" name="TextBox 23"/>
+          <p:cNvSpPr txBox="1"/>
+          <p:nvPr/>
+        </p:nvSpPr>
+        <p:spPr>
+          <a:xfrm>
+            <a:off x="1295400" y="5054600"/>
+            <a:ext cx="6210300" cy="364998"/>
+          </a:xfrm>
+          <a:prstGeom prst="rect">
+            <a:avLst/>
+          </a:prstGeom>
+          <a:noFill/>
+        </p:spPr>
+        <p:txBody>
+          <a:bodyPr wrap="none" lIns="0" rIns="0" tIns="0" bIns="0" anchor="t">
+            <a:spAutoFit/>
+          </a:bodyPr>
+          <a:lstStyle/>
+          <a:p>
+            <a:pPr>
+              <a:lnSpc>
+                <a:spcPts val="2074"/>
+              </a:lnSpc>
+              <a:spcBef>
+                <a:spcPts val="0"/>
+              </a:spcBef>
+              <a:spcAft>
+                <a:spcPts val="0"/>
+              </a:spcAft>
+            </a:pPr>
+            <a:r>
+              <a:rPr sz="1700" b="1" i="0">
+                <a:solidFill>
+                  <a:srgbClr val="392C42"/>
+                </a:solidFill>
+                <a:latin typeface="Arial"/>
+              </a:rPr>
+              <a:t>Personal interview | near internship</a:t>
+            </a:r>
+          </a:p>
+        </p:txBody>
+      </p:sp>
+      <p:sp>
+        <p:nvSpPr>
+          <p:cNvPr id="25" name="Rounded Rectangle 24"/>
           <p:cNvSpPr/>
           <p:nvPr/>
         </p:nvSpPr>
@@ -15359,7 +15479,7 @@
       </p:sp>
       <p:sp>
         <p:nvSpPr>
-          <p:cNvPr id="23" name="TextBox 22"/>
+          <p:cNvPr id="26" name="TextBox 25"/>
           <p:cNvSpPr txBox="1"/>
           <p:nvPr/>
         </p:nvSpPr>
@@ -15404,7 +15524,7 @@
       </p:sp>
       <p:pic>
         <p:nvPicPr>
-          <p:cNvPr id="24" name="Picture 23" descr="product_gamepad.png"/>
+          <p:cNvPr id="27" name="Picture 26" descr="product_gamepad.png"/>
           <p:cNvPicPr>
             <a:picLocks noChangeAspect="1"/>
           </p:cNvPicPr>
@@ -15429,7 +15549,7 @@
       </p:pic>
       <p:sp>
         <p:nvSpPr>
-          <p:cNvPr id="25" name="TextBox 24"/>
+          <p:cNvPr id="28" name="TextBox 27"/>
           <p:cNvSpPr txBox="1"/>
           <p:nvPr/>
         </p:nvSpPr>
@@ -15498,7 +15618,7 @@
       </p:sp>
       <p:sp>
         <p:nvSpPr>
-          <p:cNvPr id="26" name="TextBox 25"/>
+          <p:cNvPr id="29" name="TextBox 28"/>
           <p:cNvSpPr txBox="1"/>
           <p:nvPr/>
         </p:nvSpPr>
@@ -15543,7 +15663,7 @@
       </p:sp>
       <p:cxnSp>
         <p:nvCxnSpPr>
-          <p:cNvPr id="27" name="Connector 26"/>
+          <p:cNvPr id="30" name="Connector 29"/>
           <p:cNvCxnSpPr/>
           <p:nvPr/>
         </p:nvCxnSpPr>
@@ -15578,7 +15698,7 @@
       </p:cxnSp>
       <p:sp>
         <p:nvSpPr>
-          <p:cNvPr id="28" name="TextBox 27"/>
+          <p:cNvPr id="31" name="TextBox 30"/>
           <p:cNvSpPr txBox="1"/>
           <p:nvPr/>
         </p:nvSpPr>
@@ -15616,7 +15736,7 @@
                 </a:solidFill>
                 <a:latin typeface="Arial"/>
               </a:rPr>
-              <a:t>Prototype activity is simulated. Original fieldwork is pending. The order-demo video is embedded on slide 11.</a:t>
+              <a:t>Prototype activity is simulated. Initial informal interview included. The order-demo video is embedded on slide 11.</a:t>
             </a:r>
           </a:p>
         </p:txBody>
@@ -17464,7 +17584,7 @@
                 </a:solidFill>
                 <a:latin typeface="Arial"/>
               </a:rPr>
-              <a:t>A promising signal.</a:t>
+              <a:t>A local interview.</a:t>
             </a:r>
           </a:p>
           <a:p>
@@ -17486,7 +17606,7 @@
                 </a:solidFill>
                 <a:latin typeface="Arial"/>
               </a:rPr>
-              <a:t>An evidence gap to close.</a:t>
+              <a:t>A signal of adult interest.</a:t>
             </a:r>
           </a:p>
         </p:txBody>
@@ -17545,38 +17665,38 @@
         <p:spPr>
           <a:xfrm>
             <a:off x="850900" y="2959100"/>
-            <a:ext cx="3543300" cy="234950"/>
-          </a:xfrm>
-          <a:prstGeom prst="rect">
-            <a:avLst/>
-          </a:prstGeom>
-          <a:noFill/>
-        </p:spPr>
-        <p:txBody>
-          <a:bodyPr wrap="none" lIns="0" rIns="0" tIns="0" bIns="0" anchor="t">
-            <a:spAutoFit/>
-          </a:bodyPr>
-          <a:lstStyle/>
-          <a:p>
-            <a:pPr>
-              <a:lnSpc>
-                <a:spcPts val="1050"/>
-              </a:lnSpc>
-              <a:spcBef>
-                <a:spcPts val="0"/>
-              </a:spcBef>
-              <a:spcAft>
-                <a:spcPts val="0"/>
-              </a:spcAft>
-            </a:pPr>
-            <a:r>
-              <a:rPr sz="700" b="0" i="0">
+            <a:ext cx="3543300" cy="254000"/>
+          </a:xfrm>
+          <a:prstGeom prst="rect">
+            <a:avLst/>
+          </a:prstGeom>
+          <a:noFill/>
+        </p:spPr>
+        <p:txBody>
+          <a:bodyPr wrap="none" lIns="0" rIns="0" tIns="0" bIns="0" anchor="t">
+            <a:spAutoFit/>
+          </a:bodyPr>
+          <a:lstStyle/>
+          <a:p>
+            <a:pPr>
+              <a:lnSpc>
+                <a:spcPts val="1200"/>
+              </a:lnSpc>
+              <a:spcBef>
+                <a:spcPts val="0"/>
+              </a:spcBef>
+              <a:spcAft>
+                <a:spcPts val="0"/>
+              </a:spcAft>
+            </a:pPr>
+            <a:r>
+              <a:rPr sz="800" b="0" i="0">
                 <a:solidFill>
                   <a:srgbClr val="392C42"/>
                 </a:solidFill>
                 <a:latin typeface="Press Start 2P"/>
               </a:rPr>
-              <a:t>WHAT THE SECOND REPORT FOUND</a:t>
+              <a:t>INTERVIEW / PARAPHRASE</a:t>
             </a:r>
           </a:p>
         </p:txBody>
@@ -17589,61 +17709,83 @@
         </p:nvSpPr>
         <p:spPr>
           <a:xfrm>
-            <a:off x="850900" y="3492500"/>
-            <a:ext cx="3530600" cy="990600"/>
-          </a:xfrm>
-          <a:prstGeom prst="rect">
-            <a:avLst/>
-          </a:prstGeom>
-          <a:noFill/>
-        </p:spPr>
-        <p:txBody>
-          <a:bodyPr wrap="none" lIns="0" rIns="0" tIns="0" bIns="0" anchor="t">
-            <a:spAutoFit/>
-          </a:bodyPr>
-          <a:lstStyle/>
-          <a:p>
-            <a:pPr>
-              <a:lnSpc>
-                <a:spcPts val="3500"/>
-              </a:lnSpc>
-              <a:spcBef>
-                <a:spcPts val="0"/>
-              </a:spcBef>
-              <a:spcAft>
-                <a:spcPts val="0"/>
-              </a:spcAft>
-            </a:pPr>
-            <a:r>
-              <a:rPr sz="2900" b="1" i="0">
+            <a:off x="850900" y="3479800"/>
+            <a:ext cx="3530600" cy="1397000"/>
+          </a:xfrm>
+          <a:prstGeom prst="rect">
+            <a:avLst/>
+          </a:prstGeom>
+          <a:noFill/>
+        </p:spPr>
+        <p:txBody>
+          <a:bodyPr wrap="none" lIns="0" rIns="0" tIns="0" bIns="0" anchor="t">
+            <a:spAutoFit/>
+          </a:bodyPr>
+          <a:lstStyle/>
+          <a:p>
+            <a:pPr>
+              <a:lnSpc>
+                <a:spcPts val="3400"/>
+              </a:lnSpc>
+              <a:spcBef>
+                <a:spcPts val="0"/>
+              </a:spcBef>
+              <a:spcAft>
+                <a:spcPts val="0"/>
+              </a:spcAft>
+            </a:pPr>
+            <a:r>
+              <a:rPr sz="2800" b="1" i="0">
                 <a:solidFill>
                   <a:srgbClr val="392C42"/>
                 </a:solidFill>
                 <a:latin typeface="Arial"/>
               </a:rPr>
-              <a:t>Mainly children</a:t>
-            </a:r>
-          </a:p>
-          <a:p>
-            <a:pPr>
-              <a:lnSpc>
-                <a:spcPts val="3500"/>
-              </a:lnSpc>
-              <a:spcBef>
-                <a:spcPts val="0"/>
-              </a:spcBef>
-              <a:spcAft>
-                <a:spcPts val="0"/>
-              </a:spcAft>
-            </a:pPr>
-            <a:r>
-              <a:rPr sz="2900" b="1" i="0">
+              <a:t>Working adults</a:t>
+            </a:r>
+          </a:p>
+          <a:p>
+            <a:pPr>
+              <a:lnSpc>
+                <a:spcPts val="3400"/>
+              </a:lnSpc>
+              <a:spcBef>
+                <a:spcPts val="0"/>
+              </a:spcBef>
+              <a:spcAft>
+                <a:spcPts val="0"/>
+              </a:spcAft>
+            </a:pPr>
+            <a:r>
+              <a:rPr sz="2800" b="1" i="0">
                 <a:solidFill>
                   <a:srgbClr val="392C42"/>
                 </a:solidFill>
                 <a:latin typeface="Arial"/>
               </a:rPr>
-              <a:t>and teenagers.</a:t>
+              <a:t>also come to</a:t>
+            </a:r>
+          </a:p>
+          <a:p>
+            <a:pPr>
+              <a:lnSpc>
+                <a:spcPts val="3400"/>
+              </a:lnSpc>
+              <a:spcBef>
+                <a:spcPts val="0"/>
+              </a:spcBef>
+              <a:spcAft>
+                <a:spcPts val="0"/>
+              </a:spcAft>
+            </a:pPr>
+            <a:r>
+              <a:rPr sz="2800" b="1" i="0">
+                <a:solidFill>
+                  <a:srgbClr val="392C42"/>
+                </a:solidFill>
+                <a:latin typeface="Arial"/>
+              </a:rPr>
+              <a:t>squeeze and play.</a:t>
             </a:r>
           </a:p>
         </p:txBody>
@@ -17656,83 +17798,61 @@
         </p:nvSpPr>
         <p:spPr>
           <a:xfrm>
-            <a:off x="850900" y="4660900"/>
-            <a:ext cx="3517900" cy="1016000"/>
-          </a:xfrm>
-          <a:prstGeom prst="rect">
-            <a:avLst/>
-          </a:prstGeom>
-          <a:noFill/>
-        </p:spPr>
-        <p:txBody>
-          <a:bodyPr wrap="none" lIns="0" rIns="0" tIns="0" bIns="0" anchor="t">
-            <a:spAutoFit/>
-          </a:bodyPr>
-          <a:lstStyle/>
-          <a:p>
-            <a:pPr>
-              <a:lnSpc>
-                <a:spcPts val="2400"/>
-              </a:lnSpc>
-              <a:spcBef>
-                <a:spcPts val="0"/>
-              </a:spcBef>
-              <a:spcAft>
-                <a:spcPts val="0"/>
-              </a:spcAft>
-            </a:pPr>
-            <a:r>
-              <a:rPr sz="1700" b="0" i="0">
+            <a:off x="850900" y="5080000"/>
+            <a:ext cx="3517900" cy="635000"/>
+          </a:xfrm>
+          <a:prstGeom prst="rect">
+            <a:avLst/>
+          </a:prstGeom>
+          <a:noFill/>
+        </p:spPr>
+        <p:txBody>
+          <a:bodyPr wrap="none" lIns="0" rIns="0" tIns="0" bIns="0" anchor="t">
+            <a:spAutoFit/>
+          </a:bodyPr>
+          <a:lstStyle/>
+          <a:p>
+            <a:pPr>
+              <a:lnSpc>
+                <a:spcPts val="2100"/>
+              </a:lnSpc>
+              <a:spcBef>
+                <a:spcPts val="0"/>
+              </a:spcBef>
+              <a:spcAft>
+                <a:spcPts val="0"/>
+              </a:spcAft>
+            </a:pPr>
+            <a:r>
+              <a:rPr sz="1500" b="0" i="0">
                 <a:solidFill>
                   <a:srgbClr val="776C7B"/>
                 </a:solidFill>
                 <a:latin typeface="Arial"/>
               </a:rPr>
-              <a:t>Thairath’s Mega Plaza visit does not</a:t>
-            </a:r>
-          </a:p>
-          <a:p>
-            <a:pPr>
-              <a:lnSpc>
-                <a:spcPts val="2400"/>
-              </a:lnSpc>
-              <a:spcBef>
-                <a:spcPts val="0"/>
-              </a:spcBef>
-              <a:spcAft>
-                <a:spcPts val="0"/>
-              </a:spcAft>
-            </a:pPr>
-            <a:r>
-              <a:rPr sz="1700" b="0" i="0">
+              <a:t>Reported by the interviewee.</a:t>
+            </a:r>
+          </a:p>
+          <a:p>
+            <a:pPr>
+              <a:lnSpc>
+                <a:spcPts val="2100"/>
+              </a:lnSpc>
+              <a:spcBef>
+                <a:spcPts val="0"/>
+              </a:spcBef>
+              <a:spcAft>
+                <a:spcPts val="0"/>
+              </a:spcAft>
+            </a:pPr>
+            <a:r>
+              <a:rPr sz="1500" b="0" i="0">
                 <a:solidFill>
                   <a:srgbClr val="776C7B"/>
                 </a:solidFill>
                 <a:latin typeface="Arial"/>
               </a:rPr>
-              <a:t>independently establish adult</a:t>
-            </a:r>
-          </a:p>
-          <a:p>
-            <a:pPr>
-              <a:lnSpc>
-                <a:spcPts val="2400"/>
-              </a:lnSpc>
-              <a:spcBef>
-                <a:spcPts val="0"/>
-              </a:spcBef>
-              <a:spcAft>
-                <a:spcPts val="0"/>
-              </a:spcAft>
-            </a:pPr>
-            <a:r>
-              <a:rPr sz="1700" b="0" i="0">
-                <a:solidFill>
-                  <a:srgbClr val="776C7B"/>
-                </a:solidFill>
-                <a:latin typeface="Arial"/>
-              </a:rPr>
-              <a:t>demand.</a:t>
+              <a:t>No customer count supplied.</a:t>
             </a:r>
           </a:p>
         </p:txBody>
@@ -17822,7 +17942,7 @@
                 </a:solidFill>
                 <a:latin typeface="Arial"/>
               </a:rPr>
-              <a:t>Confirm the buyer</a:t>
+              <a:t>Source</a:t>
             </a:r>
           </a:p>
         </p:txBody>
@@ -17836,22 +17956,22 @@
         <p:spPr>
           <a:xfrm>
             <a:off x="5842000" y="3225800"/>
-            <a:ext cx="5778500" cy="349504"/>
-          </a:xfrm>
-          <a:prstGeom prst="rect">
-            <a:avLst/>
-          </a:prstGeom>
-          <a:noFill/>
-        </p:spPr>
-        <p:txBody>
-          <a:bodyPr wrap="none" lIns="0" rIns="0" tIns="0" bIns="0" anchor="t">
-            <a:spAutoFit/>
-          </a:bodyPr>
-          <a:lstStyle/>
-          <a:p>
-            <a:pPr>
-              <a:lnSpc>
-                <a:spcPts val="1952"/>
+            <a:ext cx="5778500" cy="635000"/>
+          </a:xfrm>
+          <a:prstGeom prst="rect">
+            <a:avLst/>
+          </a:prstGeom>
+          <a:noFill/>
+        </p:spPr>
+        <p:txBody>
+          <a:bodyPr wrap="none" lIns="0" rIns="0" tIns="0" bIns="0" anchor="t">
+            <a:spAutoFit/>
+          </a:bodyPr>
+          <a:lstStyle/>
+          <a:p>
+            <a:pPr>
+              <a:lnSpc>
+                <a:spcPts val="2100"/>
               </a:lnSpc>
               <a:spcBef>
                 <a:spcPts val="0"/>
@@ -17867,7 +17987,29 @@
                 </a:solidFill>
                 <a:latin typeface="Arial"/>
               </a:rPr>
-              <a:t>Working status, recent purchase and purpose.</a:t>
+              <a:t>Informal interview at a market</a:t>
+            </a:r>
+          </a:p>
+          <a:p>
+            <a:pPr>
+              <a:lnSpc>
+                <a:spcPts val="2100"/>
+              </a:lnSpc>
+              <a:spcBef>
+                <a:spcPts val="0"/>
+              </a:spcBef>
+              <a:spcAft>
+                <a:spcPts val="0"/>
+              </a:spcAft>
+            </a:pPr>
+            <a:r>
+              <a:rPr sz="1600" b="0" i="0">
+                <a:solidFill>
+                  <a:srgbClr val="776C7B"/>
+                </a:solidFill>
+                <a:latin typeface="Arial"/>
+              </a:rPr>
+              <a:t>near my internship.</a:t>
             </a:r>
           </a:p>
         </p:txBody>
@@ -17880,7 +18022,7 @@
         </p:nvCxnSpPr>
         <p:spPr>
           <a:xfrm>
-            <a:off x="5130800" y="3657600"/>
+            <a:off x="5130800" y="3771900"/>
             <a:ext cx="6477000" cy="0"/>
           </a:xfrm>
           <a:prstGeom prst="line">
@@ -17992,7 +18134,7 @@
                 </a:solidFill>
                 <a:latin typeface="Arial"/>
               </a:rPr>
-              <a:t>Ask before the concept</a:t>
+              <a:t>What it suggests</a:t>
             </a:r>
           </a:p>
         </p:txBody>
@@ -18006,22 +18148,22 @@
         <p:spPr>
           <a:xfrm>
             <a:off x="5842000" y="4305300"/>
-            <a:ext cx="5778500" cy="349504"/>
-          </a:xfrm>
-          <a:prstGeom prst="rect">
-            <a:avLst/>
-          </a:prstGeom>
-          <a:noFill/>
-        </p:spPr>
-        <p:txBody>
-          <a:bodyPr wrap="none" lIns="0" rIns="0" tIns="0" bIns="0" anchor="t">
-            <a:spAutoFit/>
-          </a:bodyPr>
-          <a:lstStyle/>
-          <a:p>
-            <a:pPr>
-              <a:lnSpc>
-                <a:spcPts val="1952"/>
+            <a:ext cx="5778500" cy="635000"/>
+          </a:xfrm>
+          <a:prstGeom prst="rect">
+            <a:avLst/>
+          </a:prstGeom>
+          <a:noFill/>
+        </p:spPr>
+        <p:txBody>
+          <a:bodyPr wrap="none" lIns="0" rIns="0" tIns="0" bIns="0" anchor="t">
+            <a:spAutoFit/>
+          </a:bodyPr>
+          <a:lstStyle/>
+          <a:p>
+            <a:pPr>
+              <a:lnSpc>
+                <a:spcPts val="2100"/>
               </a:lnSpc>
               <a:spcBef>
                 <a:spcPts val="0"/>
@@ -18037,7 +18179,29 @@
                 </a:solidFill>
                 <a:latin typeface="Arial"/>
               </a:rPr>
-              <a:t>Memory and discovery, in the buyer’s words.</a:t>
+              <a:t>Adult interest in touching</a:t>
+            </a:r>
+          </a:p>
+          <a:p>
+            <a:pPr>
+              <a:lnSpc>
+                <a:spcPts val="2100"/>
+              </a:lnSpc>
+              <a:spcBef>
+                <a:spcPts val="0"/>
+              </a:spcBef>
+              <a:spcAft>
+                <a:spcPts val="0"/>
+              </a:spcAft>
+            </a:pPr>
+            <a:r>
+              <a:rPr sz="1600" b="0" i="0">
+                <a:solidFill>
+                  <a:srgbClr val="776C7B"/>
+                </a:solidFill>
+                <a:latin typeface="Arial"/>
+              </a:rPr>
+              <a:t>and trying the toys.</a:t>
             </a:r>
           </a:p>
         </p:txBody>
@@ -18050,7 +18214,7 @@
         </p:nvCxnSpPr>
         <p:spPr>
           <a:xfrm>
-            <a:off x="5130800" y="4737100"/>
+            <a:off x="5130800" y="4851400"/>
             <a:ext cx="6477000" cy="0"/>
           </a:xfrm>
           <a:prstGeom prst="line">
@@ -18162,7 +18326,7 @@
                 </a:solidFill>
                 <a:latin typeface="Arial"/>
               </a:rPr>
-              <a:t>Keep the evidence</a:t>
+              <a:t>What remains unknown</a:t>
             </a:r>
           </a:p>
         </p:txBody>
@@ -18176,22 +18340,22 @@
         <p:spPr>
           <a:xfrm>
             <a:off x="5842000" y="5384800"/>
-            <a:ext cx="5778500" cy="349504"/>
-          </a:xfrm>
-          <a:prstGeom prst="rect">
-            <a:avLst/>
-          </a:prstGeom>
-          <a:noFill/>
-        </p:spPr>
-        <p:txBody>
-          <a:bodyPr wrap="none" lIns="0" rIns="0" tIns="0" bIns="0" anchor="t">
-            <a:spAutoFit/>
-          </a:bodyPr>
-          <a:lstStyle/>
-          <a:p>
-            <a:pPr>
-              <a:lnSpc>
-                <a:spcPts val="1952"/>
+            <a:ext cx="5778500" cy="635000"/>
+          </a:xfrm>
+          <a:prstGeom prst="rect">
+            <a:avLst/>
+          </a:prstGeom>
+          <a:noFill/>
+        </p:spPr>
+        <p:txBody>
+          <a:bodyPr wrap="none" lIns="0" rIns="0" tIns="0" bIns="0" anchor="t">
+            <a:spAutoFit/>
+          </a:bodyPr>
+          <a:lstStyle/>
+          <a:p>
+            <a:pPr>
+              <a:lnSpc>
+                <a:spcPts val="2100"/>
               </a:lnSpc>
               <a:spcBef>
                 <a:spcPts val="0"/>
@@ -18207,7 +18371,29 @@
                 </a:solidFill>
                 <a:latin typeface="Arial"/>
               </a:rPr>
-              <a:t>Date, sample size, photo and a consented quote.</a:t>
+              <a:t>Purchases, nostalgia and</a:t>
+            </a:r>
+          </a:p>
+          <a:p>
+            <a:pPr>
+              <a:lnSpc>
+                <a:spcPts val="2100"/>
+              </a:lnSpc>
+              <a:spcBef>
+                <a:spcPts val="0"/>
+              </a:spcBef>
+              <a:spcAft>
+                <a:spcPts val="0"/>
+              </a:spcAft>
+            </a:pPr>
+            <a:r>
+              <a:rPr sz="1600" b="0" i="0">
+                <a:solidFill>
+                  <a:srgbClr val="776C7B"/>
+                </a:solidFill>
+                <a:latin typeface="Arial"/>
+              </a:rPr>
+              <a:t>change in demand over time.</a:t>
             </a:r>
           </a:p>
         </p:txBody>
@@ -18220,7 +18406,7 @@
         </p:nvCxnSpPr>
         <p:spPr>
           <a:xfrm>
-            <a:off x="5130800" y="5816600"/>
+            <a:off x="5130800" y="5930900"/>
             <a:ext cx="6477000" cy="0"/>
           </a:xfrm>
           <a:prstGeom prst="line">
@@ -18321,9 +18507,8 @@
                   <a:srgbClr val="776C7B"/>
                 </a:solidFill>
                 <a:latin typeface="Arial"/>
-                <a:hlinkClick r:id="rId2"/>
-              </a:rPr>
-              <a:t>S2 / Original fieldwork is pending. Replace this research plan with your own findings before submission.</a:t>
+              </a:rPr>
+              <a:t>S6 / Personally collected interview, paraphrased in English. A qualitative account, not a measured trend.</a:t>
             </a:r>
           </a:p>
         </p:txBody>
@@ -20160,7 +20345,7 @@
                 <a:latin typeface="Arial"/>
                 <a:hlinkClick r:id="rId2"/>
               </a:rPr>
-              <a:t>S1 / Interpretation of the reported adult-return account. No medical benefit or price premium is established.</a:t>
+              <a:t>S1 / Reported childhood wishes. S6 / Reported adult play. Motives and price premium still need testing.</a:t>
             </a:r>
           </a:p>
         </p:txBody>

</xml_diff>